<commit_message>
Update Inference Extension intro for new figures and add ext_proc to Envoy post
- Rewrite Inference Extension intro around redrawn Figure 1 (istiod
  pipeline with InferencePool Controller, single model composition)
- Resize Figure 2 to 800px and include the gateway-namespace Gateway in
  the example with its reproduction manifest
- Add ext_proc filter description to the Envoy traffic processing post
- Update redrawn figures in the Istio Gateway API post
</commit_message>
<xml_diff>
--- a/content/docs/theory-analysis/istio-gateway-api/images/images.pptx
+++ b/content/docs/theory-analysis/istio-gateway-api/images/images.pptx
@@ -51389,7 +51389,7 @@
         </p:nvCxnSpPr>
         <p:spPr>
           <a:xfrm>
-            <a:off x="6496305" y="2732921"/>
+            <a:off x="6496305" y="3278557"/>
             <a:ext cx="323569" cy="0"/>
           </a:xfrm>
           <a:prstGeom prst="straightConnector1">
@@ -51433,7 +51433,7 @@
         </p:nvSpPr>
         <p:spPr>
           <a:xfrm>
-            <a:off x="6792048" y="2623151"/>
+            <a:off x="6792048" y="3168787"/>
             <a:ext cx="702455" cy="230832"/>
           </a:xfrm>
           <a:prstGeom prst="rect">
@@ -51471,7 +51471,7 @@
         </p:nvCxnSpPr>
         <p:spPr>
           <a:xfrm>
-            <a:off x="6496305" y="2979561"/>
+            <a:off x="6496305" y="3525197"/>
             <a:ext cx="323569" cy="0"/>
           </a:xfrm>
           <a:prstGeom prst="straightConnector1">
@@ -51515,7 +51515,7 @@
         </p:nvSpPr>
         <p:spPr>
           <a:xfrm>
-            <a:off x="6792048" y="2869791"/>
+            <a:off x="6792048" y="3415427"/>
             <a:ext cx="702455" cy="230832"/>
           </a:xfrm>
           <a:prstGeom prst="rect">
@@ -51992,7 +51992,7 @@
         </p:nvCxnSpPr>
         <p:spPr>
           <a:xfrm>
-            <a:off x="6496305" y="3228227"/>
+            <a:off x="6496305" y="3773863"/>
             <a:ext cx="323569" cy="0"/>
           </a:xfrm>
           <a:prstGeom prst="straightConnector1">
@@ -52036,7 +52036,7 @@
         </p:nvSpPr>
         <p:spPr>
           <a:xfrm>
-            <a:off x="6792048" y="3118457"/>
+            <a:off x="6792048" y="3664093"/>
             <a:ext cx="702455" cy="230832"/>
           </a:xfrm>
           <a:prstGeom prst="rect">
@@ -52631,14 +52631,13 @@
           <p:cNvCxnSpPr>
             <a:cxnSpLocks/>
             <a:stCxn id="76" idx="2"/>
-            <a:endCxn id="9" idx="0"/>
           </p:cNvCxnSpPr>
           <p:nvPr/>
         </p:nvCxnSpPr>
         <p:spPr>
           <a:xfrm>
             <a:off x="3481375" y="995651"/>
-            <a:ext cx="3780035" cy="232415"/>
+            <a:ext cx="3781236" cy="279941"/>
           </a:xfrm>
           <a:prstGeom prst="straightConnector1">
             <a:avLst/>
@@ -52684,8 +52683,8 @@
         </p:nvCxnSpPr>
         <p:spPr>
           <a:xfrm flipH="1">
-            <a:off x="5592488" y="2345666"/>
-            <a:ext cx="1670123" cy="1618111"/>
+            <a:off x="5592488" y="2291160"/>
+            <a:ext cx="1670123" cy="1672617"/>
           </a:xfrm>
           <a:prstGeom prst="straightConnector1">
             <a:avLst/>
@@ -52731,8 +52730,8 @@
         </p:nvCxnSpPr>
         <p:spPr>
           <a:xfrm flipV="1">
-            <a:off x="5592488" y="1709231"/>
-            <a:ext cx="257111" cy="950932"/>
+            <a:off x="5592488" y="1717698"/>
+            <a:ext cx="0" cy="942465"/>
           </a:xfrm>
           <a:prstGeom prst="straightConnector1">
             <a:avLst/>
@@ -52868,14 +52867,15 @@
           </p:cNvPr>
           <p:cNvCxnSpPr>
             <a:cxnSpLocks/>
+            <a:stCxn id="4" idx="2"/>
             <a:endCxn id="159" idx="0"/>
           </p:cNvCxnSpPr>
           <p:nvPr/>
         </p:nvCxnSpPr>
         <p:spPr>
           <a:xfrm flipH="1">
-            <a:off x="4273463" y="2345666"/>
-            <a:ext cx="2989148" cy="1618111"/>
+            <a:off x="4273463" y="2291501"/>
+            <a:ext cx="2989148" cy="1672276"/>
           </a:xfrm>
           <a:prstGeom prst="straightConnector1">
             <a:avLst/>
@@ -53071,6 +53071,52 @@
           <a:ln w="12700">
             <a:solidFill>
               <a:schemeClr val="tx1"/>
+            </a:solidFill>
+            <a:prstDash val="solid"/>
+            <a:headEnd type="none" w="med" len="med"/>
+            <a:tailEnd type="triangle" w="med" len="med"/>
+          </a:ln>
+        </p:spPr>
+        <p:style>
+          <a:lnRef idx="1">
+            <a:schemeClr val="accent1"/>
+          </a:lnRef>
+          <a:fillRef idx="0">
+            <a:schemeClr val="accent1"/>
+          </a:fillRef>
+          <a:effectRef idx="0">
+            <a:schemeClr val="accent1"/>
+          </a:effectRef>
+          <a:fontRef idx="minor">
+            <a:schemeClr val="tx1"/>
+          </a:fontRef>
+        </p:style>
+      </p:cxnSp>
+      <p:cxnSp>
+        <p:nvCxnSpPr>
+          <p:cNvPr id="23" name="직선 화살표 연결선 96">
+            <a:extLst>
+              <a:ext uri="{FF2B5EF4-FFF2-40B4-BE49-F238E27FC236}">
+                <a16:creationId xmlns:a16="http://schemas.microsoft.com/office/drawing/2014/main" id="{1AD9A679-0EDE-7719-78BF-29A4F3B77CE4}"/>
+              </a:ext>
+            </a:extLst>
+          </p:cNvPr>
+          <p:cNvCxnSpPr>
+            <a:cxnSpLocks/>
+          </p:cNvCxnSpPr>
+          <p:nvPr/>
+        </p:nvCxnSpPr>
+        <p:spPr>
+          <a:xfrm>
+            <a:off x="7380312" y="1718380"/>
+            <a:ext cx="0" cy="130333"/>
+          </a:xfrm>
+          <a:prstGeom prst="straightConnector1">
+            <a:avLst/>
+          </a:prstGeom>
+          <a:ln w="12700">
+            <a:solidFill>
+              <a:srgbClr val="C00000"/>
             </a:solidFill>
             <a:prstDash val="solid"/>
             <a:headEnd type="none" w="med" len="med"/>
@@ -54528,14 +54574,14 @@
           <p:cNvCxnSpPr>
             <a:cxnSpLocks/>
             <a:stCxn id="76" idx="2"/>
-            <a:endCxn id="15" idx="0"/>
+            <a:endCxn id="6" idx="0"/>
           </p:cNvCxnSpPr>
           <p:nvPr/>
         </p:nvCxnSpPr>
         <p:spPr>
           <a:xfrm flipH="1">
             <a:off x="2162350" y="995651"/>
-            <a:ext cx="1319025" cy="232415"/>
+            <a:ext cx="1319025" cy="279941"/>
           </a:xfrm>
           <a:prstGeom prst="straightConnector1">
             <a:avLst/>
@@ -54575,15 +54621,15 @@
           </p:cNvPr>
           <p:cNvCxnSpPr>
             <a:cxnSpLocks/>
-            <a:stCxn id="15" idx="2"/>
+            <a:stCxn id="5" idx="2"/>
             <a:endCxn id="159" idx="0"/>
           </p:cNvCxnSpPr>
           <p:nvPr/>
         </p:nvCxnSpPr>
         <p:spPr>
           <a:xfrm>
-            <a:off x="2162350" y="2345666"/>
-            <a:ext cx="2111113" cy="1618111"/>
+            <a:off x="2162350" y="2294444"/>
+            <a:ext cx="2111113" cy="1669333"/>
           </a:xfrm>
           <a:prstGeom prst="straightConnector1">
             <a:avLst/>
@@ -54623,15 +54669,15 @@
           </p:cNvPr>
           <p:cNvCxnSpPr>
             <a:cxnSpLocks/>
-            <a:stCxn id="15" idx="2"/>
+            <a:stCxn id="5" idx="2"/>
             <a:endCxn id="160" idx="0"/>
           </p:cNvCxnSpPr>
           <p:nvPr/>
         </p:nvCxnSpPr>
         <p:spPr>
           <a:xfrm>
-            <a:off x="2162350" y="2345666"/>
-            <a:ext cx="3430138" cy="1618111"/>
+            <a:off x="2162350" y="2294444"/>
+            <a:ext cx="3430138" cy="1669333"/>
           </a:xfrm>
           <a:prstGeom prst="straightConnector1">
             <a:avLst/>
@@ -54925,6 +54971,52 @@
           <a:ln w="12700">
             <a:solidFill>
               <a:schemeClr val="tx1"/>
+            </a:solidFill>
+            <a:prstDash val="solid"/>
+            <a:headEnd type="none" w="med" len="med"/>
+            <a:tailEnd type="triangle" w="med" len="med"/>
+          </a:ln>
+        </p:spPr>
+        <p:style>
+          <a:lnRef idx="1">
+            <a:schemeClr val="accent1"/>
+          </a:lnRef>
+          <a:fillRef idx="0">
+            <a:schemeClr val="accent1"/>
+          </a:fillRef>
+          <a:effectRef idx="0">
+            <a:schemeClr val="accent1"/>
+          </a:effectRef>
+          <a:fontRef idx="minor">
+            <a:schemeClr val="tx1"/>
+          </a:fontRef>
+        </p:style>
+      </p:cxnSp>
+      <p:cxnSp>
+        <p:nvCxnSpPr>
+          <p:cNvPr id="13" name="직선 화살표 연결선 96">
+            <a:extLst>
+              <a:ext uri="{FF2B5EF4-FFF2-40B4-BE49-F238E27FC236}">
+                <a16:creationId xmlns:a16="http://schemas.microsoft.com/office/drawing/2014/main" id="{DC067B9A-12EC-7B20-0194-5076370F62E4}"/>
+              </a:ext>
+            </a:extLst>
+          </p:cNvPr>
+          <p:cNvCxnSpPr>
+            <a:cxnSpLocks/>
+          </p:cNvCxnSpPr>
+          <p:nvPr/>
+        </p:nvCxnSpPr>
+        <p:spPr>
+          <a:xfrm>
+            <a:off x="2051720" y="1718380"/>
+            <a:ext cx="0" cy="133276"/>
+          </a:xfrm>
+          <a:prstGeom prst="straightConnector1">
+            <a:avLst/>
+          </a:prstGeom>
+          <a:ln w="12700">
+            <a:solidFill>
+              <a:srgbClr val="C00000"/>
             </a:solidFill>
             <a:prstDash val="solid"/>
             <a:headEnd type="none" w="med" len="med"/>

</xml_diff>